<commit_message>
Corrige mapa do slide 9, ajusta slide 6 e cria versão para mesários
- Slide 9: encurta a faixa da Merrion Road para não passar atrás do
  Ring 3 e move o rótulo do Portão B para fora da caixa do Hall 2
- Slide 3: remove o chip "EM DECISÃO"
- Slide 6: esclarece que apoio não é mesário, remove a discussão sobre
  trocar a Mariá de lugar
- Novo slide antes do 13: documentos aceitos, com o espírito da norma
  (documento oficial e com foto, qualquer nacionalidade)
- Nova versão geral para mesários, sem os slides de dias de folga,
  equipe de apoio e apoio e voluntários

Co-Authored-By: Claude Sonnet 5 <noreply@anthropic.com>
Claude-Session: https://claude.ai/code/session_01DUb8AtDBYD92NcmXwGpgQA
</commit_message>
<xml_diff>
--- a/Apresentações/2026.9.23_Equipe Embaixada_Briefing.pptx
+++ b/Apresentações/2026.9.23_Equipe Embaixada_Briefing.pptx
@@ -20,6 +20,7 @@
     <p:sldId id="270" r:id="rId11"/>
     <p:sldId id="264" r:id="rId12"/>
     <p:sldId id="265" r:id="rId13"/>
+    <p:sldId id="271" r:id="rId22"/>
     <p:sldId id="266" r:id="rId14"/>
     <p:sldId id="267" r:id="rId15"/>
     <p:sldId id="268" r:id="rId16"/>
@@ -11137,6 +11138,1032 @@
 
 <file path=ppt/slides/slide13.xml><?xml version="1.0" encoding="utf-8"?>
 <p:sld xmlns:a="http://schemas.openxmlformats.org/drawingml/2006/main" xmlns:r="http://schemas.openxmlformats.org/officeDocument/2006/relationships" xmlns:p="http://schemas.openxmlformats.org/presentationml/2006/main">
+  <p:cSld name="Slide 9">
+    <p:spTree>
+      <p:nvGrpSpPr>
+        <p:cNvPr id="1" name=""/>
+        <p:cNvGrpSpPr/>
+        <p:nvPr/>
+      </p:nvGrpSpPr>
+      <p:grpSpPr>
+        <a:xfrm>
+          <a:off x="0" y="0"/>
+          <a:ext cx="0" cy="0"/>
+          <a:chOff x="0" y="0"/>
+          <a:chExt cx="0" cy="0"/>
+        </a:xfrm>
+      </p:grpSpPr>
+      <p:sp>
+        <p:nvSpPr>
+          <p:cNvPr id="2" name="Shape 0"/>
+          <p:cNvSpPr/>
+          <p:nvPr/>
+        </p:nvSpPr>
+        <p:spPr>
+          <a:xfrm>
+            <a:off x="0" y="0"/>
+            <a:ext cx="12191695" cy="6858000"/>
+          </a:xfrm>
+          <a:prstGeom prst="rect">
+            <a:avLst/>
+          </a:prstGeom>
+          <a:solidFill>
+            <a:srgbClr val="F2EFE2"/>
+          </a:solidFill>
+          <a:ln/>
+        </p:spPr>
+        <p:txBody>
+          <a:bodyPr/>
+          <a:lstStyle/>
+          <a:p>
+            <a:endParaRPr lang="en-IE"/>
+          </a:p>
+        </p:txBody>
+      </p:sp>
+      <p:sp>
+        <p:nvSpPr>
+          <p:cNvPr id="3" name="Shape 1"/>
+          <p:cNvSpPr/>
+          <p:nvPr/>
+        </p:nvSpPr>
+        <p:spPr>
+          <a:xfrm>
+            <a:off x="0" y="0"/>
+            <a:ext cx="12191695" cy="118872"/>
+          </a:xfrm>
+          <a:prstGeom prst="rect">
+            <a:avLst/>
+          </a:prstGeom>
+          <a:solidFill>
+            <a:srgbClr val="042B5A"/>
+          </a:solidFill>
+          <a:ln/>
+        </p:spPr>
+        <p:txBody>
+          <a:bodyPr/>
+          <a:lstStyle/>
+          <a:p>
+            <a:endParaRPr lang="en-IE"/>
+          </a:p>
+        </p:txBody>
+      </p:sp>
+      <p:sp>
+        <p:nvSpPr>
+          <p:cNvPr id="4" name="Text 2"/>
+          <p:cNvSpPr txBox="1"/>
+          <p:nvPr/>
+        </p:nvSpPr>
+        <p:spPr>
+          <a:xfrm>
+            <a:off x="566928" y="384048"/>
+            <a:ext cx="7315200" cy="182880"/>
+          </a:xfrm>
+          <a:prstGeom prst="rect">
+            <a:avLst/>
+          </a:prstGeom>
+          <a:noFill/>
+          <a:ln/>
+        </p:spPr>
+        <p:txBody>
+          <a:bodyPr wrap="square" lIns="0" tIns="0" rIns="0" bIns="0" rtlCol="0" anchor="t"/>
+          <a:lstStyle/>
+          <a:p>
+            <a:pPr marL="0" indent="0">
+              <a:buNone/>
+            </a:pPr>
+            <a:r>
+              <a:rPr lang="en-US" sz="900" b="1" kern="0" spc="160" dirty="0">
+                <a:solidFill>
+                  <a:srgbClr val="5F882E"/>
+                </a:solidFill>
+                <a:latin typeface="Montserrat" pitchFamily="34" charset="0"/>
+                <a:ea typeface="Montserrat" pitchFamily="34" charset="-122"/>
+                <a:cs typeface="Montserrat" pitchFamily="34" charset="-120"/>
+              </a:rPr>
+              <a:t>IDENTIFICAÇÃO</a:t>
+            </a:r>
+            <a:endParaRPr lang="en-US" sz="900" dirty="0"/>
+          </a:p>
+        </p:txBody>
+      </p:sp>
+      <p:sp>
+        <p:nvSpPr>
+          <p:cNvPr id="5" name="Text 3"/>
+          <p:cNvSpPr txBox="1"/>
+          <p:nvPr/>
+        </p:nvSpPr>
+        <p:spPr>
+          <a:xfrm>
+            <a:off x="566928" y="603504"/>
+            <a:ext cx="8778240" cy="512064"/>
+          </a:xfrm>
+          <a:prstGeom prst="rect">
+            <a:avLst/>
+          </a:prstGeom>
+          <a:noFill/>
+          <a:ln/>
+        </p:spPr>
+        <p:txBody>
+          <a:bodyPr wrap="square" lIns="0" tIns="0" rIns="0" bIns="0" rtlCol="0" anchor="t"/>
+          <a:lstStyle/>
+          <a:p>
+            <a:pPr marL="0" indent="0">
+              <a:buNone/>
+            </a:pPr>
+            <a:r>
+              <a:rPr lang="en-US" sz="3000" b="1" dirty="0">
+                <a:solidFill>
+                  <a:srgbClr val="042B5A"/>
+                </a:solidFill>
+                <a:latin typeface="Montserrat" pitchFamily="34" charset="0"/>
+                <a:ea typeface="Montserrat" pitchFamily="34" charset="-122"/>
+                <a:cs typeface="Montserrat" pitchFamily="34" charset="-120"/>
+              </a:rPr>
+              <a:t>Qualquer documento oficial, com foto</a:t>
+            </a:r>
+            <a:endParaRPr lang="en-US" sz="3000" dirty="0"/>
+          </a:p>
+        </p:txBody>
+      </p:sp>
+      <p:sp>
+        <p:nvSpPr>
+          <p:cNvPr id="6" name="Text 4"/>
+          <p:cNvSpPr txBox="1"/>
+          <p:nvPr/>
+        </p:nvSpPr>
+        <p:spPr>
+          <a:xfrm>
+            <a:off x="566928" y="1152144"/>
+            <a:ext cx="7863840" cy="365760"/>
+          </a:xfrm>
+          <a:prstGeom prst="rect">
+            <a:avLst/>
+          </a:prstGeom>
+          <a:noFill/>
+          <a:ln/>
+        </p:spPr>
+        <p:txBody>
+          <a:bodyPr wrap="square" lIns="0" tIns="0" rIns="0" bIns="0" rtlCol="0" anchor="t"/>
+          <a:lstStyle/>
+          <a:p>
+            <a:pPr marL="0" indent="0">
+              <a:lnSpc>
+                <a:spcPts val="1700"/>
+              </a:lnSpc>
+              <a:buNone/>
+            </a:pPr>
+            <a:r>
+              <a:rPr lang="en-US" sz="1200" dirty="0">
+                <a:solidFill>
+                  <a:srgbClr val="6B6B6B"/>
+                </a:solidFill>
+                <a:latin typeface="Montserrat" pitchFamily="34" charset="0"/>
+                <a:ea typeface="Montserrat" pitchFamily="34" charset="-122"/>
+                <a:cs typeface="Montserrat" pitchFamily="34" charset="-120"/>
+              </a:rPr>
+              <a:t>O espírito da norma é simples: confirmar que é a mesma pessoa. Não importa se o documento é brasileiro, irlandês ou de outra nacionalidade.</a:t>
+            </a:r>
+            <a:endParaRPr lang="en-US" sz="1200" dirty="0"/>
+          </a:p>
+        </p:txBody>
+      </p:sp>
+      <p:sp>
+        <p:nvSpPr>
+          <p:cNvPr id="7" name="Shape 5"/>
+          <p:cNvSpPr/>
+          <p:nvPr/>
+        </p:nvSpPr>
+        <p:spPr>
+          <a:xfrm>
+            <a:off x="566928" y="2194560"/>
+            <a:ext cx="2558720" cy="2834640"/>
+          </a:xfrm>
+          <a:prstGeom prst="roundRect">
+            <a:avLst>
+              <a:gd name="adj" fmla="val 1787"/>
+            </a:avLst>
+          </a:prstGeom>
+          <a:solidFill>
+            <a:srgbClr val="FFFFFF"/>
+          </a:solidFill>
+          <a:ln w="9525">
+            <a:solidFill>
+              <a:srgbClr val="E4DFCC"/>
+            </a:solidFill>
+            <a:prstDash val="solid"/>
+          </a:ln>
+        </p:spPr>
+        <p:txBody>
+          <a:bodyPr/>
+          <a:lstStyle/>
+          <a:p>
+            <a:endParaRPr lang="en-IE"/>
+          </a:p>
+        </p:txBody>
+      </p:sp>
+      <p:sp>
+        <p:nvSpPr>
+          <p:cNvPr id="8" name="Shape 6"/>
+          <p:cNvSpPr/>
+          <p:nvPr/>
+        </p:nvSpPr>
+        <p:spPr>
+          <a:xfrm>
+            <a:off x="877824" y="2505456"/>
+            <a:ext cx="548640" cy="548640"/>
+          </a:xfrm>
+          <a:prstGeom prst="ellipse">
+            <a:avLst/>
+          </a:prstGeom>
+          <a:solidFill>
+            <a:srgbClr val="5F882E"/>
+          </a:solidFill>
+          <a:ln/>
+        </p:spPr>
+        <p:txBody>
+          <a:bodyPr/>
+          <a:lstStyle/>
+          <a:p>
+            <a:endParaRPr lang="en-IE"/>
+          </a:p>
+        </p:txBody>
+      </p:sp>
+      <p:sp>
+        <p:nvSpPr>
+          <p:cNvPr id="9" name="Text 7"/>
+          <p:cNvSpPr txBox="1"/>
+          <p:nvPr/>
+        </p:nvSpPr>
+        <p:spPr>
+          <a:xfrm>
+            <a:off x="877824" y="2505456"/>
+            <a:ext cx="548640" cy="548640"/>
+          </a:xfrm>
+          <a:prstGeom prst="rect">
+            <a:avLst/>
+          </a:prstGeom>
+          <a:noFill/>
+          <a:ln/>
+        </p:spPr>
+        <p:txBody>
+          <a:bodyPr wrap="square" lIns="0" tIns="0" rIns="0" bIns="0" rtlCol="0" anchor="ctr"/>
+          <a:lstStyle/>
+          <a:p>
+            <a:pPr marL="0" indent="0" algn="ctr">
+              <a:buNone/>
+            </a:pPr>
+            <a:r>
+              <a:rPr lang="en-US" sz="1400" b="1" dirty="0">
+                <a:solidFill>
+                  <a:srgbClr val="FFFFFF"/>
+                </a:solidFill>
+                <a:latin typeface="Montserrat" pitchFamily="34" charset="0"/>
+                <a:ea typeface="Montserrat" pitchFamily="34" charset="-122"/>
+                <a:cs typeface="Montserrat" pitchFamily="34" charset="-120"/>
+              </a:rPr>
+              <a:t>BR</a:t>
+            </a:r>
+            <a:endParaRPr lang="en-US" sz="1800" dirty="0"/>
+          </a:p>
+        </p:txBody>
+      </p:sp>
+      <p:sp>
+        <p:nvSpPr>
+          <p:cNvPr id="10" name="Text 8"/>
+          <p:cNvSpPr txBox="1"/>
+          <p:nvPr/>
+        </p:nvSpPr>
+        <p:spPr>
+          <a:xfrm>
+            <a:off x="877824" y="3200400"/>
+            <a:ext cx="1936928" cy="310896"/>
+          </a:xfrm>
+          <a:prstGeom prst="rect">
+            <a:avLst/>
+          </a:prstGeom>
+          <a:noFill/>
+          <a:ln/>
+        </p:spPr>
+        <p:txBody>
+          <a:bodyPr wrap="square" lIns="0" tIns="0" rIns="0" bIns="0" rtlCol="0" anchor="t"/>
+          <a:lstStyle/>
+          <a:p>
+            <a:pPr marL="0" indent="0">
+              <a:buNone/>
+            </a:pPr>
+            <a:r>
+              <a:rPr lang="en-US" sz="1700" b="1" dirty="0">
+                <a:solidFill>
+                  <a:srgbClr val="042B5A"/>
+                </a:solidFill>
+                <a:latin typeface="Montserrat" pitchFamily="34" charset="0"/>
+                <a:ea typeface="Montserrat" pitchFamily="34" charset="-122"/>
+                <a:cs typeface="Montserrat" pitchFamily="34" charset="-120"/>
+              </a:rPr>
+              <a:t>Documento brasileiro</a:t>
+            </a:r>
+            <a:endParaRPr lang="en-US" sz="1700" dirty="0"/>
+          </a:p>
+        </p:txBody>
+      </p:sp>
+      <p:sp>
+        <p:nvSpPr>
+          <p:cNvPr id="11" name="Text 9"/>
+          <p:cNvSpPr txBox="1"/>
+          <p:nvPr/>
+        </p:nvSpPr>
+        <p:spPr>
+          <a:xfrm>
+            <a:off x="877824" y="3621024"/>
+            <a:ext cx="1936928" cy="1188720"/>
+          </a:xfrm>
+          <a:prstGeom prst="rect">
+            <a:avLst/>
+          </a:prstGeom>
+          <a:noFill/>
+          <a:ln/>
+        </p:spPr>
+        <p:txBody>
+          <a:bodyPr wrap="square" lIns="0" tIns="0" rIns="0" bIns="0" rtlCol="0" anchor="t"/>
+          <a:lstStyle/>
+          <a:p>
+            <a:pPr marL="0" indent="0">
+              <a:lnSpc>
+                <a:spcPts val="1450"/>
+              </a:lnSpc>
+              <a:buNone/>
+            </a:pPr>
+            <a:r>
+              <a:rPr lang="en-US" sz="1000" dirty="0">
+                <a:solidFill>
+                  <a:srgbClr val="6B6B6B"/>
+                </a:solidFill>
+                <a:latin typeface="Montserrat" pitchFamily="34" charset="0"/>
+                <a:ea typeface="Montserrat" pitchFamily="34" charset="-122"/>
+                <a:cs typeface="Montserrat" pitchFamily="34" charset="-120"/>
+              </a:rPr>
+              <a:t>RG, CNH, passaporte, carteira de trabalho ou funcional — qualquer documento oficial brasileiro, com foto.</a:t>
+            </a:r>
+            <a:endParaRPr lang="en-US" sz="1000" dirty="0"/>
+          </a:p>
+        </p:txBody>
+      </p:sp>
+      <p:sp>
+        <p:nvSpPr>
+          <p:cNvPr id="12" name="Shape 10"/>
+          <p:cNvSpPr/>
+          <p:nvPr/>
+        </p:nvSpPr>
+        <p:spPr>
+          <a:xfrm>
+            <a:off x="3399968" y="2194560"/>
+            <a:ext cx="2558720" cy="2834640"/>
+          </a:xfrm>
+          <a:prstGeom prst="roundRect">
+            <a:avLst>
+              <a:gd name="adj" fmla="val 1787"/>
+            </a:avLst>
+          </a:prstGeom>
+          <a:solidFill>
+            <a:srgbClr val="FFFFFF"/>
+          </a:solidFill>
+          <a:ln w="9525">
+            <a:solidFill>
+              <a:srgbClr val="E4DFCC"/>
+            </a:solidFill>
+            <a:prstDash val="solid"/>
+          </a:ln>
+        </p:spPr>
+        <p:txBody>
+          <a:bodyPr/>
+          <a:lstStyle/>
+          <a:p>
+            <a:endParaRPr lang="en-IE"/>
+          </a:p>
+        </p:txBody>
+      </p:sp>
+      <p:sp>
+        <p:nvSpPr>
+          <p:cNvPr id="13" name="Shape 11"/>
+          <p:cNvSpPr/>
+          <p:nvPr/>
+        </p:nvSpPr>
+        <p:spPr>
+          <a:xfrm>
+            <a:off x="3710864" y="2505456"/>
+            <a:ext cx="548640" cy="548640"/>
+          </a:xfrm>
+          <a:prstGeom prst="ellipse">
+            <a:avLst/>
+          </a:prstGeom>
+          <a:solidFill>
+            <a:srgbClr val="33507E"/>
+          </a:solidFill>
+          <a:ln/>
+        </p:spPr>
+        <p:txBody>
+          <a:bodyPr/>
+          <a:lstStyle/>
+          <a:p>
+            <a:endParaRPr lang="en-IE"/>
+          </a:p>
+        </p:txBody>
+      </p:sp>
+      <p:sp>
+        <p:nvSpPr>
+          <p:cNvPr id="14" name="Text 12"/>
+          <p:cNvSpPr txBox="1"/>
+          <p:nvPr/>
+        </p:nvSpPr>
+        <p:spPr>
+          <a:xfrm>
+            <a:off x="3710864" y="2505456"/>
+            <a:ext cx="548640" cy="548640"/>
+          </a:xfrm>
+          <a:prstGeom prst="rect">
+            <a:avLst/>
+          </a:prstGeom>
+          <a:noFill/>
+          <a:ln/>
+        </p:spPr>
+        <p:txBody>
+          <a:bodyPr wrap="square" lIns="0" tIns="0" rIns="0" bIns="0" rtlCol="0" anchor="ctr"/>
+          <a:lstStyle/>
+          <a:p>
+            <a:pPr marL="0" indent="0" algn="ctr">
+              <a:buNone/>
+            </a:pPr>
+            <a:r>
+              <a:rPr lang="en-US" sz="1400" b="1" dirty="0">
+                <a:solidFill>
+                  <a:srgbClr val="FFFFFF"/>
+                </a:solidFill>
+                <a:latin typeface="Montserrat" pitchFamily="34" charset="0"/>
+                <a:ea typeface="Montserrat" pitchFamily="34" charset="-122"/>
+                <a:cs typeface="Montserrat" pitchFamily="34" charset="-120"/>
+              </a:rPr>
+              <a:t>IE</a:t>
+            </a:r>
+            <a:endParaRPr lang="en-US" sz="1400" dirty="0"/>
+          </a:p>
+        </p:txBody>
+      </p:sp>
+      <p:sp>
+        <p:nvSpPr>
+          <p:cNvPr id="15" name="Text 13"/>
+          <p:cNvSpPr txBox="1"/>
+          <p:nvPr/>
+        </p:nvSpPr>
+        <p:spPr>
+          <a:xfrm>
+            <a:off x="3710864" y="3200400"/>
+            <a:ext cx="1936928" cy="310896"/>
+          </a:xfrm>
+          <a:prstGeom prst="rect">
+            <a:avLst/>
+          </a:prstGeom>
+          <a:noFill/>
+          <a:ln/>
+        </p:spPr>
+        <p:txBody>
+          <a:bodyPr wrap="square" lIns="0" tIns="0" rIns="0" bIns="0" rtlCol="0" anchor="t"/>
+          <a:lstStyle/>
+          <a:p>
+            <a:pPr marL="0" indent="0">
+              <a:buNone/>
+            </a:pPr>
+            <a:r>
+              <a:rPr lang="en-US" sz="1700" b="1" dirty="0">
+                <a:solidFill>
+                  <a:srgbClr val="042B5A"/>
+                </a:solidFill>
+                <a:latin typeface="Montserrat" pitchFamily="34" charset="0"/>
+                <a:ea typeface="Montserrat" pitchFamily="34" charset="-122"/>
+                <a:cs typeface="Montserrat" pitchFamily="34" charset="-120"/>
+              </a:rPr>
+              <a:t>Documento irlandês</a:t>
+            </a:r>
+            <a:endParaRPr lang="en-US" sz="1700" dirty="0"/>
+          </a:p>
+        </p:txBody>
+      </p:sp>
+      <p:sp>
+        <p:nvSpPr>
+          <p:cNvPr id="16" name="Text 14"/>
+          <p:cNvSpPr txBox="1"/>
+          <p:nvPr/>
+        </p:nvSpPr>
+        <p:spPr>
+          <a:xfrm>
+            <a:off x="3710864" y="3621024"/>
+            <a:ext cx="1936928" cy="1188720"/>
+          </a:xfrm>
+          <a:prstGeom prst="rect">
+            <a:avLst/>
+          </a:prstGeom>
+          <a:noFill/>
+          <a:ln/>
+        </p:spPr>
+        <p:txBody>
+          <a:bodyPr wrap="square" lIns="0" tIns="0" rIns="0" bIns="0" rtlCol="0" anchor="t"/>
+          <a:lstStyle/>
+          <a:p>
+            <a:pPr marL="0" indent="0">
+              <a:lnSpc>
+                <a:spcPts val="1450"/>
+              </a:lnSpc>
+              <a:buNone/>
+            </a:pPr>
+            <a:r>
+              <a:rPr lang="en-US" sz="1000" dirty="0">
+                <a:solidFill>
+                  <a:srgbClr val="6B6B6B"/>
+                </a:solidFill>
+                <a:latin typeface="Montserrat" pitchFamily="34" charset="0"/>
+                <a:ea typeface="Montserrat" pitchFamily="34" charset="-122"/>
+                <a:cs typeface="Montserrat" pitchFamily="34" charset="-120"/>
+              </a:rPr>
+              <a:t>Passport card, driving licence ou outro documento oficial irlandês, com foto.</a:t>
+            </a:r>
+            <a:endParaRPr lang="en-US" sz="1000" dirty="0"/>
+          </a:p>
+        </p:txBody>
+      </p:sp>
+      <p:sp>
+        <p:nvSpPr>
+          <p:cNvPr id="17" name="Shape 15"/>
+          <p:cNvSpPr/>
+          <p:nvPr/>
+        </p:nvSpPr>
+        <p:spPr>
+          <a:xfrm>
+            <a:off x="6233008" y="2194560"/>
+            <a:ext cx="2558720" cy="2834640"/>
+          </a:xfrm>
+          <a:prstGeom prst="roundRect">
+            <a:avLst>
+              <a:gd name="adj" fmla="val 1787"/>
+            </a:avLst>
+          </a:prstGeom>
+          <a:solidFill>
+            <a:srgbClr val="FFFFFF"/>
+          </a:solidFill>
+          <a:ln w="9525">
+            <a:solidFill>
+              <a:srgbClr val="E4DFCC"/>
+            </a:solidFill>
+            <a:prstDash val="solid"/>
+          </a:ln>
+        </p:spPr>
+        <p:txBody>
+          <a:bodyPr/>
+          <a:lstStyle/>
+          <a:p>
+            <a:endParaRPr lang="en-IE"/>
+          </a:p>
+        </p:txBody>
+      </p:sp>
+      <p:sp>
+        <p:nvSpPr>
+          <p:cNvPr id="18" name="Shape 16"/>
+          <p:cNvSpPr/>
+          <p:nvPr/>
+        </p:nvSpPr>
+        <p:spPr>
+          <a:xfrm>
+            <a:off x="6543904" y="2505456"/>
+            <a:ext cx="548640" cy="548640"/>
+          </a:xfrm>
+          <a:prstGeom prst="ellipse">
+            <a:avLst/>
+          </a:prstGeom>
+          <a:solidFill>
+            <a:srgbClr val="33507E"/>
+          </a:solidFill>
+          <a:ln/>
+        </p:spPr>
+        <p:txBody>
+          <a:bodyPr/>
+          <a:lstStyle/>
+          <a:p>
+            <a:endParaRPr lang="en-IE"/>
+          </a:p>
+        </p:txBody>
+      </p:sp>
+      <p:sp>
+        <p:nvSpPr>
+          <p:cNvPr id="19" name="Text 17"/>
+          <p:cNvSpPr txBox="1"/>
+          <p:nvPr/>
+        </p:nvSpPr>
+        <p:spPr>
+          <a:xfrm>
+            <a:off x="6543904" y="2505456"/>
+            <a:ext cx="548640" cy="548640"/>
+          </a:xfrm>
+          <a:prstGeom prst="rect">
+            <a:avLst/>
+          </a:prstGeom>
+          <a:noFill/>
+          <a:ln/>
+        </p:spPr>
+        <p:txBody>
+          <a:bodyPr wrap="square" lIns="0" tIns="0" rIns="0" bIns="0" rtlCol="0" anchor="ctr"/>
+          <a:lstStyle/>
+          <a:p>
+            <a:pPr marL="0" indent="0" algn="ctr">
+              <a:buNone/>
+            </a:pPr>
+            <a:r>
+              <a:rPr lang="en-US" sz="1100" b="1" dirty="0">
+                <a:solidFill>
+                  <a:srgbClr val="FFFFFF"/>
+                </a:solidFill>
+                <a:latin typeface="Montserrat" pitchFamily="34" charset="0"/>
+                <a:ea typeface="Montserrat" pitchFamily="34" charset="-122"/>
+                <a:cs typeface="Montserrat" pitchFamily="34" charset="-120"/>
+              </a:rPr>
+              <a:t>OUT</a:t>
+            </a:r>
+            <a:endParaRPr lang="en-US" sz="1400" dirty="0"/>
+          </a:p>
+        </p:txBody>
+      </p:sp>
+      <p:sp>
+        <p:nvSpPr>
+          <p:cNvPr id="20" name="Text 18"/>
+          <p:cNvSpPr txBox="1"/>
+          <p:nvPr/>
+        </p:nvSpPr>
+        <p:spPr>
+          <a:xfrm>
+            <a:off x="6543904" y="3200400"/>
+            <a:ext cx="1936928" cy="310896"/>
+          </a:xfrm>
+          <a:prstGeom prst="rect">
+            <a:avLst/>
+          </a:prstGeom>
+          <a:noFill/>
+          <a:ln/>
+        </p:spPr>
+        <p:txBody>
+          <a:bodyPr wrap="square" lIns="0" tIns="0" rIns="0" bIns="0" rtlCol="0" anchor="t"/>
+          <a:lstStyle/>
+          <a:p>
+            <a:pPr marL="0" indent="0">
+              <a:buNone/>
+            </a:pPr>
+            <a:r>
+              <a:rPr lang="en-US" sz="1700" b="1" dirty="0">
+                <a:solidFill>
+                  <a:srgbClr val="042B5A"/>
+                </a:solidFill>
+                <a:latin typeface="Montserrat" pitchFamily="34" charset="0"/>
+                <a:ea typeface="Montserrat" pitchFamily="34" charset="-122"/>
+                <a:cs typeface="Montserrat" pitchFamily="34" charset="-120"/>
+              </a:rPr>
+              <a:t>Documento de outro país</a:t>
+            </a:r>
+            <a:endParaRPr lang="en-US" sz="1700" dirty="0"/>
+          </a:p>
+        </p:txBody>
+      </p:sp>
+      <p:sp>
+        <p:nvSpPr>
+          <p:cNvPr id="21" name="Text 19"/>
+          <p:cNvSpPr txBox="1"/>
+          <p:nvPr/>
+        </p:nvSpPr>
+        <p:spPr>
+          <a:xfrm>
+            <a:off x="6543904" y="3621024"/>
+            <a:ext cx="1936928" cy="1188720"/>
+          </a:xfrm>
+          <a:prstGeom prst="rect">
+            <a:avLst/>
+          </a:prstGeom>
+          <a:noFill/>
+          <a:ln/>
+        </p:spPr>
+        <p:txBody>
+          <a:bodyPr wrap="square" lIns="0" tIns="0" rIns="0" bIns="0" rtlCol="0" anchor="t"/>
+          <a:lstStyle/>
+          <a:p>
+            <a:pPr marL="0" indent="0">
+              <a:lnSpc>
+                <a:spcPts val="1450"/>
+              </a:lnSpc>
+              <a:buNone/>
+            </a:pPr>
+            <a:r>
+              <a:rPr lang="en-US" sz="1000" dirty="0">
+                <a:solidFill>
+                  <a:srgbClr val="6B6B6B"/>
+                </a:solidFill>
+                <a:latin typeface="Montserrat" pitchFamily="34" charset="0"/>
+                <a:ea typeface="Montserrat" pitchFamily="34" charset="-122"/>
+                <a:cs typeface="Montserrat" pitchFamily="34" charset="-120"/>
+              </a:rPr>
+              <a:t>Vale também o passaporte de um terceiro país — por exemplo, o italiano de um binacional. Basta ser oficial e ter foto.</a:t>
+            </a:r>
+            <a:endParaRPr lang="en-US" sz="1000" dirty="0"/>
+          </a:p>
+        </p:txBody>
+      </p:sp>
+      <p:sp>
+        <p:nvSpPr>
+          <p:cNvPr id="22" name="Shape 20"/>
+          <p:cNvSpPr/>
+          <p:nvPr/>
+        </p:nvSpPr>
+        <p:spPr>
+          <a:xfrm>
+            <a:off x="9066047" y="2194560"/>
+            <a:ext cx="2558720" cy="2834640"/>
+          </a:xfrm>
+          <a:prstGeom prst="roundRect">
+            <a:avLst>
+              <a:gd name="adj" fmla="val 1787"/>
+            </a:avLst>
+          </a:prstGeom>
+          <a:solidFill>
+            <a:srgbClr val="FFFFFF"/>
+          </a:solidFill>
+          <a:ln w="9525">
+            <a:solidFill>
+              <a:srgbClr val="E4DFCC"/>
+            </a:solidFill>
+            <a:prstDash val="solid"/>
+          </a:ln>
+        </p:spPr>
+        <p:txBody>
+          <a:bodyPr/>
+          <a:lstStyle/>
+          <a:p>
+            <a:endParaRPr lang="en-IE"/>
+          </a:p>
+        </p:txBody>
+      </p:sp>
+      <p:sp>
+        <p:nvSpPr>
+          <p:cNvPr id="23" name="Shape 21"/>
+          <p:cNvSpPr/>
+          <p:nvPr/>
+        </p:nvSpPr>
+        <p:spPr>
+          <a:xfrm>
+            <a:off x="9376943" y="2505456"/>
+            <a:ext cx="548640" cy="548640"/>
+          </a:xfrm>
+          <a:prstGeom prst="ellipse">
+            <a:avLst/>
+          </a:prstGeom>
+          <a:solidFill>
+            <a:srgbClr val="C8102E"/>
+          </a:solidFill>
+          <a:ln/>
+        </p:spPr>
+        <p:txBody>
+          <a:bodyPr/>
+          <a:lstStyle/>
+          <a:p>
+            <a:endParaRPr lang="en-IE"/>
+          </a:p>
+        </p:txBody>
+      </p:sp>
+      <p:sp>
+        <p:nvSpPr>
+          <p:cNvPr id="24" name="Text 22"/>
+          <p:cNvSpPr txBox="1"/>
+          <p:nvPr/>
+        </p:nvSpPr>
+        <p:spPr>
+          <a:xfrm>
+            <a:off x="9376943" y="2505456"/>
+            <a:ext cx="548640" cy="548640"/>
+          </a:xfrm>
+          <a:prstGeom prst="rect">
+            <a:avLst/>
+          </a:prstGeom>
+          <a:noFill/>
+          <a:ln/>
+        </p:spPr>
+        <p:txBody>
+          <a:bodyPr wrap="square" lIns="0" tIns="0" rIns="0" bIns="0" rtlCol="0" anchor="ctr"/>
+          <a:lstStyle/>
+          <a:p>
+            <a:pPr marL="0" indent="0" algn="ctr">
+              <a:buNone/>
+            </a:pPr>
+            <a:r>
+              <a:rPr lang="en-US" sz="1800" b="1" dirty="0">
+                <a:solidFill>
+                  <a:srgbClr val="FFFFFF"/>
+                </a:solidFill>
+                <a:latin typeface="Montserrat" pitchFamily="34" charset="0"/>
+                <a:ea typeface="Montserrat" pitchFamily="34" charset="-122"/>
+                <a:cs typeface="Montserrat" pitchFamily="34" charset="-120"/>
+              </a:rPr>
+              <a:t>OK</a:t>
+            </a:r>
+            <a:endParaRPr lang="en-US" sz="1800" dirty="0"/>
+          </a:p>
+        </p:txBody>
+      </p:sp>
+      <p:sp>
+        <p:nvSpPr>
+          <p:cNvPr id="25" name="Text 23"/>
+          <p:cNvSpPr txBox="1"/>
+          <p:nvPr/>
+        </p:nvSpPr>
+        <p:spPr>
+          <a:xfrm>
+            <a:off x="9376943" y="3200400"/>
+            <a:ext cx="1936928" cy="310896"/>
+          </a:xfrm>
+          <a:prstGeom prst="rect">
+            <a:avLst/>
+          </a:prstGeom>
+          <a:noFill/>
+          <a:ln/>
+        </p:spPr>
+        <p:txBody>
+          <a:bodyPr wrap="square" lIns="0" tIns="0" rIns="0" bIns="0" rtlCol="0" anchor="t"/>
+          <a:lstStyle/>
+          <a:p>
+            <a:pPr marL="0" indent="0">
+              <a:buNone/>
+            </a:pPr>
+            <a:r>
+              <a:rPr lang="en-US" sz="1700" b="1" dirty="0">
+                <a:solidFill>
+                  <a:srgbClr val="042B5A"/>
+                </a:solidFill>
+                <a:latin typeface="Montserrat" pitchFamily="34" charset="0"/>
+                <a:ea typeface="Montserrat" pitchFamily="34" charset="-122"/>
+                <a:cs typeface="Montserrat" pitchFamily="34" charset="-120"/>
+              </a:rPr>
+              <a:t>O que importa sempre</a:t>
+            </a:r>
+            <a:endParaRPr lang="en-US" sz="1700" dirty="0"/>
+          </a:p>
+        </p:txBody>
+      </p:sp>
+      <p:sp>
+        <p:nvSpPr>
+          <p:cNvPr id="26" name="Text 24"/>
+          <p:cNvSpPr txBox="1"/>
+          <p:nvPr/>
+        </p:nvSpPr>
+        <p:spPr>
+          <a:xfrm>
+            <a:off x="9376943" y="3621024"/>
+            <a:ext cx="1936928" cy="1188720"/>
+          </a:xfrm>
+          <a:prstGeom prst="rect">
+            <a:avLst/>
+          </a:prstGeom>
+          <a:noFill/>
+          <a:ln/>
+        </p:spPr>
+        <p:txBody>
+          <a:bodyPr wrap="square" lIns="0" tIns="0" rIns="0" bIns="0" rtlCol="0" anchor="t"/>
+          <a:lstStyle/>
+          <a:p>
+            <a:pPr marL="0" indent="0">
+              <a:lnSpc>
+                <a:spcPts val="1450"/>
+              </a:lnSpc>
+              <a:buNone/>
+            </a:pPr>
+            <a:r>
+              <a:rPr lang="en-US" sz="1000" dirty="0" err="1">
+                <a:solidFill>
+                  <a:srgbClr val="6B6B6B"/>
+                </a:solidFill>
+                <a:latin typeface="Montserrat" pitchFamily="34" charset="0"/>
+                <a:ea typeface="Montserrat" pitchFamily="34" charset="-122"/>
+                <a:cs typeface="Montserrat" pitchFamily="34" charset="-120"/>
+              </a:rPr>
+              <a:t>Confirmar que é a mesma pessoa. Documento oficial e com foto — a nacionalidade não importa.</a:t>
+            </a:r>
+            <a:endParaRPr lang="en-US" sz="1000" dirty="0"/>
+          </a:p>
+        </p:txBody>
+      </p:sp>
+      <p:sp>
+        <p:nvSpPr>
+          <p:cNvPr id="27" name="Shape 25"/>
+          <p:cNvSpPr/>
+          <p:nvPr/>
+        </p:nvSpPr>
+        <p:spPr>
+          <a:xfrm>
+            <a:off x="566928" y="5358384"/>
+            <a:ext cx="11057839" cy="877824"/>
+          </a:xfrm>
+          <a:prstGeom prst="roundRect">
+            <a:avLst>
+              <a:gd name="adj" fmla="val 5208"/>
+            </a:avLst>
+          </a:prstGeom>
+          <a:solidFill>
+            <a:srgbClr val="EDEADB"/>
+          </a:solidFill>
+          <a:ln w="9525">
+            <a:solidFill>
+              <a:srgbClr val="E4DFCC"/>
+            </a:solidFill>
+            <a:prstDash val="solid"/>
+          </a:ln>
+        </p:spPr>
+        <p:txBody>
+          <a:bodyPr/>
+          <a:lstStyle/>
+          <a:p>
+            <a:endParaRPr lang="en-IE"/>
+          </a:p>
+        </p:txBody>
+      </p:sp>
+      <p:sp>
+        <p:nvSpPr>
+          <p:cNvPr id="28" name="Shape 26"/>
+          <p:cNvSpPr/>
+          <p:nvPr/>
+        </p:nvSpPr>
+        <p:spPr>
+          <a:xfrm>
+            <a:off x="566928" y="5358384"/>
+            <a:ext cx="82296" cy="877824"/>
+          </a:xfrm>
+          <a:prstGeom prst="rect">
+            <a:avLst/>
+          </a:prstGeom>
+          <a:solidFill>
+            <a:srgbClr val="C8102E"/>
+          </a:solidFill>
+          <a:ln/>
+        </p:spPr>
+        <p:txBody>
+          <a:bodyPr/>
+          <a:lstStyle/>
+          <a:p>
+            <a:endParaRPr lang="en-IE"/>
+          </a:p>
+        </p:txBody>
+      </p:sp>
+      <p:sp>
+        <p:nvSpPr>
+          <p:cNvPr id="29" name="Text 27"/>
+          <p:cNvSpPr txBox="1"/>
+          <p:nvPr/>
+        </p:nvSpPr>
+        <p:spPr>
+          <a:xfrm>
+            <a:off x="932688" y="5358384"/>
+            <a:ext cx="10326319" cy="877824"/>
+          </a:xfrm>
+          <a:prstGeom prst="rect">
+            <a:avLst/>
+          </a:prstGeom>
+          <a:noFill/>
+          <a:ln/>
+        </p:spPr>
+        <p:txBody>
+          <a:bodyPr wrap="square" lIns="0" tIns="0" rIns="0" bIns="0" rtlCol="0" anchor="ctr"/>
+          <a:lstStyle/>
+          <a:p>
+            <a:pPr marL="0" indent="0">
+              <a:lnSpc>
+                <a:spcPts val="1600"/>
+              </a:lnSpc>
+              <a:buNone/>
+            </a:pPr>
+            <a:r>
+              <a:rPr lang="en-US" sz="1200" b="1" dirty="0" err="1">
+                <a:solidFill>
+                  <a:srgbClr val="042B5A"/>
+                </a:solidFill>
+                <a:latin typeface="Montserrat" pitchFamily="34" charset="0"/>
+                <a:ea typeface="Montserrat" pitchFamily="34" charset="-122"/>
+                <a:cs typeface="Montserrat" pitchFamily="34" charset="-120"/>
+              </a:rPr>
+              <a:t>Na dúvida, não é sobre a nacionalidade do documento — é sobre reconhecer a pessoa que está na sua frente.</a:t>
+            </a:r>
+            <a:endParaRPr lang="en-US" sz="1200" dirty="0"/>
+          </a:p>
+        </p:txBody>
+      </p:sp>
+    </p:spTree>
+  </p:cSld>
+  <p:clrMapOvr>
+    <a:masterClrMapping/>
+  </p:clrMapOvr>
+</p:sld>
+</file>
+
+<file path=ppt/slides/slide14.xml><?xml version="1.0" encoding="utf-8"?>
+<p:sld xmlns:a="http://schemas.openxmlformats.org/drawingml/2006/main" xmlns:r="http://schemas.openxmlformats.org/officeDocument/2006/relationships" xmlns:p="http://schemas.openxmlformats.org/presentationml/2006/main">
   <p:cSld name="Slide 11">
     <p:spTree>
       <p:nvGrpSpPr>
@@ -13944,7 +14971,7 @@
 </p:sld>
 </file>
 
-<file path=ppt/slides/slide14.xml><?xml version="1.0" encoding="utf-8"?>
+<file path=ppt/slides/slide15.xml><?xml version="1.0" encoding="utf-8"?>
 <p:sld xmlns:a="http://schemas.openxmlformats.org/drawingml/2006/main" xmlns:r="http://schemas.openxmlformats.org/officeDocument/2006/relationships" xmlns:p="http://schemas.openxmlformats.org/presentationml/2006/main">
   <p:cSld name="Slide 12">
     <p:spTree>
@@ -15722,7 +16749,7 @@
 </p:sld>
 </file>
 
-<file path=ppt/slides/slide15.xml><?xml version="1.0" encoding="utf-8"?>
+<file path=ppt/slides/slide16.xml><?xml version="1.0" encoding="utf-8"?>
 <p:sld xmlns:a="http://schemas.openxmlformats.org/drawingml/2006/main" xmlns:r="http://schemas.openxmlformats.org/officeDocument/2006/relationships" xmlns:p="http://schemas.openxmlformats.org/presentationml/2006/main">
   <p:cSld name="Slide 13">
     <p:spTree>
@@ -17677,7 +18704,7 @@
                 <a:ea typeface="Montserrat" pitchFamily="34" charset="-122"/>
                 <a:cs typeface="Montserrat" pitchFamily="34" charset="-120"/>
               </a:rPr>
-              <a:t>Todos são mesários. Quem, além disso, é apoio — e o que o apoio faz.</a:t>
+              <a:t>Mesário atua na mesa; apoio ajuda o fluxo — são funções diferentes.</a:t>
             </a:r>
             <a:endParaRPr lang="en-US" sz="1000" dirty="0"/>
           </a:p>
@@ -19234,74 +20261,6 @@
       </p:sp>
       <p:sp>
         <p:nvSpPr>
-          <p:cNvPr id="34" name="Shape 32"/>
-          <p:cNvSpPr/>
-          <p:nvPr/>
-        </p:nvSpPr>
-        <p:spPr>
-          <a:xfrm>
-            <a:off x="7900416" y="5138928"/>
-            <a:ext cx="1207008" cy="237744"/>
-          </a:xfrm>
-          <a:prstGeom prst="roundRect">
-            <a:avLst>
-              <a:gd name="adj" fmla="val 38462"/>
-            </a:avLst>
-          </a:prstGeom>
-          <a:solidFill>
-            <a:srgbClr val="E8C63A"/>
-          </a:solidFill>
-          <a:ln/>
-        </p:spPr>
-        <p:txBody>
-          <a:bodyPr/>
-          <a:lstStyle/>
-          <a:p>
-            <a:endParaRPr lang="en-IE"/>
-          </a:p>
-        </p:txBody>
-      </p:sp>
-      <p:sp>
-        <p:nvSpPr>
-          <p:cNvPr id="35" name="Text 33"/>
-          <p:cNvSpPr txBox="1"/>
-          <p:nvPr/>
-        </p:nvSpPr>
-        <p:spPr>
-          <a:xfrm>
-            <a:off x="7900416" y="5138928"/>
-            <a:ext cx="1207008" cy="237744"/>
-          </a:xfrm>
-          <a:prstGeom prst="rect">
-            <a:avLst/>
-          </a:prstGeom>
-          <a:noFill/>
-          <a:ln/>
-        </p:spPr>
-        <p:txBody>
-          <a:bodyPr wrap="square" lIns="0" tIns="0" rIns="0" bIns="0" rtlCol="0" anchor="ctr"/>
-          <a:lstStyle/>
-          <a:p>
-            <a:pPr marL="0" indent="0" algn="ctr">
-              <a:buNone/>
-            </a:pPr>
-            <a:r>
-              <a:rPr lang="en-US" sz="750" b="1" kern="0" spc="80" dirty="0">
-                <a:solidFill>
-                  <a:srgbClr val="042B5A"/>
-                </a:solidFill>
-                <a:latin typeface="Montserrat" pitchFamily="34" charset="0"/>
-                <a:ea typeface="Montserrat" pitchFamily="34" charset="-122"/>
-                <a:cs typeface="Montserrat" pitchFamily="34" charset="-120"/>
-              </a:rPr>
-              <a:t>EM DECISÃO</a:t>
-            </a:r>
-            <a:endParaRPr lang="en-US" sz="750" dirty="0"/>
-          </a:p>
-        </p:txBody>
-      </p:sp>
-      <p:sp>
-        <p:nvSpPr>
           <p:cNvPr id="36" name="Text 34"/>
           <p:cNvSpPr txBox="1"/>
           <p:nvPr/>
@@ -22191,7 +23150,7 @@
                 <a:ea typeface="Montserrat" pitchFamily="34" charset="-122"/>
                 <a:cs typeface="Montserrat" pitchFamily="34" charset="-120"/>
               </a:rPr>
-              <a:t>Todos são mesários</a:t>
+              <a:t>Mesário e apoio não são a mesma função</a:t>
             </a:r>
             <a:endParaRPr lang="en-US" sz="3000" dirty="0"/>
           </a:p>
@@ -22233,7 +23192,7 @@
                 <a:ea typeface="Montserrat" pitchFamily="34" charset="-122"/>
                 <a:cs typeface="Montserrat" pitchFamily="34" charset="-120"/>
               </a:rPr>
-              <a:t>O apoio não é outra equipe: é uma função a mais, para oito pessoas que também estão na mesa.</a:t>
+              <a:t>Mesário atua na mesa de votação; apoio ajuda o fluxo dos eleitores no percurso — são funções diferentes.</a:t>
             </a:r>
             <a:endParaRPr lang="en-US" sz="1200" dirty="0"/>
           </a:p>
@@ -22360,7 +23319,7 @@
         <p:spPr>
           <a:xfrm>
             <a:off x="950976" y="3163824"/>
-            <a:ext cx="3566160" cy="914400"/>
+            <a:ext cx="3566160" cy="1097280"/>
           </a:xfrm>
           <a:prstGeom prst="rect">
             <a:avLst/>
@@ -22387,7 +23346,7 @@
                 <a:ea typeface="Montserrat" pitchFamily="34" charset="-122"/>
                 <a:cs typeface="Montserrat" pitchFamily="34" charset="-120"/>
               </a:rPr>
-              <a:t>É a função nomeada, com treinamento próprio, e é a única que identifica o eleitor. Nenhuma outra pessoa no RDS confere documento.</a:t>
+              <a:t>Atua na mesa de votação. É a função nomeada, com treinamento próprio, e a única que identifica o eleitor. Ninguém mais confere documento.</a:t>
             </a:r>
             <a:endParaRPr lang="en-US" sz="1050" dirty="0"/>
           </a:p>
@@ -22468,7 +23427,7 @@
                 <a:ea typeface="Montserrat" pitchFamily="34" charset="-122"/>
                 <a:cs typeface="Montserrat" pitchFamily="34" charset="-120"/>
               </a:rPr>
-              <a:t>APOIO · 8 PESSOAS, ALÉM DE MESÁRIAS</a:t>
+              <a:t>APOIO · 8 PESSOAS, FUNÇÕES DE FLUXO</a:t>
             </a:r>
             <a:endParaRPr lang="en-US" sz="800" dirty="0"/>
           </a:p>
@@ -23152,7 +24111,7 @@
                 <a:ea typeface="Montserrat" pitchFamily="34" charset="-122"/>
                 <a:cs typeface="Montserrat" pitchFamily="34" charset="-120"/>
               </a:rPr>
-              <a:t>Em estudo:</a:t>
+              <a:t>Importante: </a:t>
             </a:r>
             <a:r>
               <a:rPr lang="en-US" sz="1100" dirty="0">
@@ -23163,7 +24122,7 @@
                 <a:ea typeface="Montserrat" pitchFamily="34" charset="-122"/>
                 <a:cs typeface="Montserrat" pitchFamily="34" charset="-120"/>
               </a:rPr>
-              <a:t>  a substituição de Mariá por Bianca no grupo de apoio. Nada muda na condição de mesária de nenhuma das duas.</a:t>
+              <a:t> apoio orienta, não decide. Não atua na mesa nem identifica ninguém — só o mesário faz isso.</a:t>
             </a:r>
             <a:endParaRPr lang="en-US" sz="1100" dirty="0"/>
           </a:p>
@@ -25644,8 +26603,8 @@
         </p:nvSpPr>
         <p:spPr>
           <a:xfrm>
-            <a:off x="3833608" y="1207008"/>
-            <a:ext cx="414816" cy="5257800"/>
+            <a:off x="4290808" y="1207008"/>
+            <a:ext cx="414816" cy="2816352"/>
           </a:xfrm>
           <a:prstGeom prst="rect">
             <a:avLst/>
@@ -25689,7 +26648,7 @@
         </p:nvSpPr>
         <p:spPr>
           <a:xfrm>
-            <a:off x="3422128" y="1725528"/>
+            <a:off x="3879328" y="1725528"/>
             <a:ext cx="1280160" cy="182880"/>
           </a:xfrm>
           <a:prstGeom prst="rect">
@@ -25728,8 +26687,8 @@
         </p:nvCxnSpPr>
         <p:spPr>
           <a:xfrm>
-            <a:off x="3750645" y="1258860"/>
-            <a:ext cx="0" cy="5154095"/>
+            <a:off x="4207845" y="1258860"/>
+            <a:ext cx="0" cy="2718779"/>
           </a:xfrm>
           <a:prstGeom prst="line">
             <a:avLst/>
@@ -25764,7 +26723,7 @@
         </p:nvSpPr>
         <p:spPr>
           <a:xfrm>
-            <a:off x="722484" y="1414416"/>
+            <a:off x="1179684" y="1414416"/>
             <a:ext cx="2608159" cy="2302231"/>
           </a:xfrm>
           <a:prstGeom prst="rect">
@@ -25811,7 +26770,7 @@
         </p:nvSpPr>
         <p:spPr>
           <a:xfrm>
-            <a:off x="722484" y="2360000"/>
+            <a:off x="1179684" y="2360000"/>
             <a:ext cx="2608159" cy="274320"/>
           </a:xfrm>
           <a:prstGeom prst="rect">
@@ -25850,7 +26809,7 @@
         </p:nvSpPr>
         <p:spPr>
           <a:xfrm>
-            <a:off x="722484" y="2640000"/>
+            <a:off x="1179684" y="2640000"/>
             <a:ext cx="2608159" cy="219456"/>
           </a:xfrm>
           <a:prstGeom prst="rect">
@@ -25889,7 +26848,7 @@
         </p:nvSpPr>
         <p:spPr>
           <a:xfrm>
-            <a:off x="722484" y="2800000"/>
+            <a:off x="1179684" y="2800000"/>
             <a:ext cx="2608159" cy="219456"/>
           </a:xfrm>
           <a:prstGeom prst="rect">
@@ -25928,7 +26887,7 @@
         </p:nvSpPr>
         <p:spPr>
           <a:xfrm>
-            <a:off x="1048374" y="3716648"/>
+            <a:off x="1505574" y="3716648"/>
             <a:ext cx="2281491" cy="725928"/>
           </a:xfrm>
           <a:prstGeom prst="rect">
@@ -25973,7 +26932,7 @@
         </p:nvSpPr>
         <p:spPr>
           <a:xfrm>
-            <a:off x="1126152" y="4017390"/>
+            <a:off x="1583352" y="4017390"/>
             <a:ext cx="1463040" cy="182880"/>
           </a:xfrm>
           <a:prstGeom prst="rect">
@@ -26012,7 +26971,7 @@
         </p:nvSpPr>
         <p:spPr>
           <a:xfrm>
-            <a:off x="1048374" y="4442577"/>
+            <a:off x="1505574" y="4442577"/>
             <a:ext cx="2281491" cy="1814822"/>
           </a:xfrm>
           <a:prstGeom prst="rect">
@@ -26060,7 +27019,7 @@
         </p:nvSpPr>
         <p:spPr>
           <a:xfrm>
-            <a:off x="3174309" y="4442577"/>
+            <a:off x="3631509" y="4442577"/>
             <a:ext cx="155556" cy="1814822"/>
           </a:xfrm>
           <a:prstGeom prst="rect">
@@ -26105,7 +27064,7 @@
         </p:nvSpPr>
         <p:spPr>
           <a:xfrm>
-            <a:off x="1048374" y="6101843"/>
+            <a:off x="1505574" y="6101843"/>
             <a:ext cx="2125934" cy="155556"/>
           </a:xfrm>
           <a:prstGeom prst="rect">
@@ -26150,7 +27109,7 @@
         </p:nvSpPr>
         <p:spPr>
           <a:xfrm>
-            <a:off x="1048374" y="6132954"/>
+            <a:off x="1505574" y="6132954"/>
             <a:ext cx="2125934" cy="182880"/>
           </a:xfrm>
           <a:prstGeom prst="rect">
@@ -26189,7 +27148,7 @@
         </p:nvSpPr>
         <p:spPr>
           <a:xfrm>
-            <a:off x="1048374" y="4442577"/>
+            <a:off x="1505574" y="4442577"/>
             <a:ext cx="667336" cy="1659266"/>
           </a:xfrm>
           <a:prstGeom prst="rect">
@@ -26238,7 +27197,7 @@
         </p:nvSpPr>
         <p:spPr>
           <a:xfrm>
-            <a:off x="1048374" y="4980000"/>
+            <a:off x="1505574" y="4980000"/>
             <a:ext cx="667336" cy="365760"/>
           </a:xfrm>
           <a:prstGeom prst="rect">
@@ -26277,7 +27236,7 @@
         </p:nvSpPr>
         <p:spPr>
           <a:xfrm>
-            <a:off x="1048374" y="5390000"/>
+            <a:off x="1505574" y="5390000"/>
             <a:ext cx="667336" cy="182880"/>
           </a:xfrm>
           <a:prstGeom prst="rect">
@@ -26316,7 +27275,7 @@
         </p:nvCxnSpPr>
         <p:spPr>
           <a:xfrm>
-            <a:off x="1048374" y="6101843"/>
+            <a:off x="1505574" y="6101843"/>
             <a:ext cx="148815" cy="0"/>
           </a:xfrm>
           <a:prstGeom prst="line">
@@ -26352,7 +27311,7 @@
         </p:nvCxnSpPr>
         <p:spPr>
           <a:xfrm>
-            <a:off x="1612006" y="4442577"/>
+            <a:off x="2069206" y="4442577"/>
             <a:ext cx="103704" cy="0"/>
           </a:xfrm>
           <a:prstGeom prst="line">
@@ -26388,7 +27347,7 @@
         </p:nvCxnSpPr>
         <p:spPr>
           <a:xfrm flipV="1">
-            <a:off x="1663858" y="3716648"/>
+            <a:off x="2121058" y="3716648"/>
             <a:ext cx="202742" cy="725929"/>
           </a:xfrm>
           <a:prstGeom prst="line">
@@ -26425,7 +27384,7 @@
         </p:nvSpPr>
         <p:spPr>
           <a:xfrm>
-            <a:off x="1777933" y="4442577"/>
+            <a:off x="2235133" y="4442577"/>
             <a:ext cx="666817" cy="1659266"/>
           </a:xfrm>
           <a:prstGeom prst="rect">
@@ -26474,7 +27433,7 @@
         </p:nvSpPr>
         <p:spPr>
           <a:xfrm>
-            <a:off x="1777933" y="4980000"/>
+            <a:off x="2235133" y="4980000"/>
             <a:ext cx="666817" cy="365760"/>
           </a:xfrm>
           <a:prstGeom prst="rect">
@@ -26513,7 +27472,7 @@
         </p:nvSpPr>
         <p:spPr>
           <a:xfrm>
-            <a:off x="1777933" y="5390000"/>
+            <a:off x="2235133" y="5390000"/>
             <a:ext cx="666817" cy="182880"/>
           </a:xfrm>
           <a:prstGeom prst="rect">
@@ -26552,7 +27511,7 @@
         </p:nvCxnSpPr>
         <p:spPr>
           <a:xfrm>
-            <a:off x="2296453" y="6101843"/>
+            <a:off x="2753653" y="6101843"/>
             <a:ext cx="148297" cy="0"/>
           </a:xfrm>
           <a:prstGeom prst="line">
@@ -26588,7 +27547,7 @@
         </p:nvCxnSpPr>
         <p:spPr>
           <a:xfrm>
-            <a:off x="2059489" y="4442577"/>
+            <a:off x="2516689" y="4442577"/>
             <a:ext cx="103705" cy="0"/>
           </a:xfrm>
           <a:prstGeom prst="line">
@@ -26624,7 +27583,7 @@
         </p:nvCxnSpPr>
         <p:spPr>
           <a:xfrm flipV="1">
-            <a:off x="2111341" y="3716648"/>
+            <a:off x="2568541" y="3716648"/>
             <a:ext cx="77779" cy="725929"/>
           </a:xfrm>
           <a:prstGeom prst="line">
@@ -26661,7 +27620,7 @@
         </p:nvSpPr>
         <p:spPr>
           <a:xfrm>
-            <a:off x="2506973" y="4442577"/>
+            <a:off x="2964173" y="4442577"/>
             <a:ext cx="667336" cy="1659266"/>
           </a:xfrm>
           <a:prstGeom prst="rect">
@@ -26710,7 +27669,7 @@
         </p:nvSpPr>
         <p:spPr>
           <a:xfrm>
-            <a:off x="2506973" y="4980000"/>
+            <a:off x="2964173" y="4980000"/>
             <a:ext cx="667336" cy="365760"/>
           </a:xfrm>
           <a:prstGeom prst="rect">
@@ -26749,7 +27708,7 @@
         </p:nvSpPr>
         <p:spPr>
           <a:xfrm>
-            <a:off x="2506973" y="5390000"/>
+            <a:off x="2964173" y="5390000"/>
             <a:ext cx="667336" cy="182880"/>
           </a:xfrm>
           <a:prstGeom prst="rect">
@@ -26788,7 +27747,7 @@
         </p:nvCxnSpPr>
         <p:spPr>
           <a:xfrm>
-            <a:off x="3025493" y="6101843"/>
+            <a:off x="3482693" y="6101843"/>
             <a:ext cx="148816" cy="0"/>
           </a:xfrm>
           <a:prstGeom prst="line">
@@ -26824,7 +27783,7 @@
         </p:nvCxnSpPr>
         <p:spPr>
           <a:xfrm>
-            <a:off x="2506973" y="4442577"/>
+            <a:off x="2964173" y="4442577"/>
             <a:ext cx="103704" cy="0"/>
           </a:xfrm>
           <a:prstGeom prst="line">
@@ -26860,7 +27819,7 @@
         </p:nvCxnSpPr>
         <p:spPr>
           <a:xfrm flipH="1" flipV="1">
-            <a:off x="2511639" y="3716648"/>
+            <a:off x="2968839" y="3716648"/>
             <a:ext cx="47186" cy="725929"/>
           </a:xfrm>
           <a:prstGeom prst="line">
@@ -26897,7 +27856,7 @@
         </p:nvCxnSpPr>
         <p:spPr>
           <a:xfrm>
-            <a:off x="1409524" y="3716648"/>
+            <a:off x="1866724" y="3716648"/>
             <a:ext cx="62222" cy="0"/>
           </a:xfrm>
           <a:prstGeom prst="line">
@@ -26933,7 +27892,7 @@
         </p:nvSpPr>
         <p:spPr>
           <a:xfrm>
-            <a:off x="1212035" y="3744080"/>
+            <a:off x="1669235" y="3744080"/>
             <a:ext cx="457200" cy="164592"/>
           </a:xfrm>
           <a:prstGeom prst="rect">
@@ -26972,7 +27931,7 @@
         </p:nvCxnSpPr>
         <p:spPr>
           <a:xfrm>
-            <a:off x="1712858" y="3716648"/>
+            <a:off x="2170058" y="3716648"/>
             <a:ext cx="307483" cy="0"/>
           </a:xfrm>
           <a:prstGeom prst="line">
@@ -27008,7 +27967,7 @@
         </p:nvSpPr>
         <p:spPr>
           <a:xfrm>
-            <a:off x="1683720" y="3497192"/>
+            <a:off x="2140920" y="3497192"/>
             <a:ext cx="365760" cy="201168"/>
           </a:xfrm>
           <a:prstGeom prst="rect">
@@ -27047,7 +28006,7 @@
         </p:nvCxnSpPr>
         <p:spPr>
           <a:xfrm>
-            <a:off x="2035378" y="3716648"/>
+            <a:off x="2492578" y="3716648"/>
             <a:ext cx="307483" cy="0"/>
           </a:xfrm>
           <a:prstGeom prst="line">
@@ -27083,7 +28042,7 @@
         </p:nvSpPr>
         <p:spPr>
           <a:xfrm>
-            <a:off x="2006240" y="3497192"/>
+            <a:off x="2463440" y="3497192"/>
             <a:ext cx="365760" cy="201168"/>
           </a:xfrm>
           <a:prstGeom prst="rect">
@@ -27122,7 +28081,7 @@
         </p:nvCxnSpPr>
         <p:spPr>
           <a:xfrm>
-            <a:off x="2357898" y="3716648"/>
+            <a:off x="2815098" y="3716648"/>
             <a:ext cx="307483" cy="0"/>
           </a:xfrm>
           <a:prstGeom prst="line">
@@ -27158,7 +28117,7 @@
         </p:nvSpPr>
         <p:spPr>
           <a:xfrm>
-            <a:off x="2328759" y="3497192"/>
+            <a:off x="2785959" y="3497192"/>
             <a:ext cx="365760" cy="201168"/>
           </a:xfrm>
           <a:prstGeom prst="rect">
@@ -27197,7 +28156,7 @@
         </p:nvCxnSpPr>
         <p:spPr>
           <a:xfrm>
-            <a:off x="2697529" y="3716648"/>
+            <a:off x="3154729" y="3716648"/>
             <a:ext cx="65852" cy="0"/>
           </a:xfrm>
           <a:prstGeom prst="line">
@@ -27233,7 +28192,7 @@
         </p:nvSpPr>
         <p:spPr>
           <a:xfrm>
-            <a:off x="2790813" y="3515480"/>
+            <a:off x="3248013" y="3515480"/>
             <a:ext cx="822960" cy="182880"/>
           </a:xfrm>
           <a:prstGeom prst="rect">
@@ -27272,7 +28231,7 @@
         </p:nvCxnSpPr>
         <p:spPr>
           <a:xfrm>
-            <a:off x="2906493" y="3716648"/>
+            <a:off x="3363693" y="3716648"/>
             <a:ext cx="62222" cy="0"/>
           </a:xfrm>
           <a:prstGeom prst="line">
@@ -27308,7 +28267,7 @@
         </p:nvSpPr>
         <p:spPr>
           <a:xfrm>
-            <a:off x="2709004" y="3744080"/>
+            <a:off x="3166204" y="3744080"/>
             <a:ext cx="457200" cy="164592"/>
           </a:xfrm>
           <a:prstGeom prst="rect">
@@ -27347,7 +28306,7 @@
         </p:nvCxnSpPr>
         <p:spPr>
           <a:xfrm flipH="1">
-            <a:off x="3538051" y="2005529"/>
+            <a:off x="3995251" y="2005529"/>
             <a:ext cx="212594" cy="0"/>
           </a:xfrm>
           <a:prstGeom prst="line">
@@ -27384,7 +28343,7 @@
         </p:nvCxnSpPr>
         <p:spPr>
           <a:xfrm>
-            <a:off x="3538051" y="2005529"/>
+            <a:off x="3995251" y="2005529"/>
             <a:ext cx="0" cy="2359270"/>
           </a:xfrm>
           <a:prstGeom prst="line">
@@ -27421,7 +28380,7 @@
         </p:nvCxnSpPr>
         <p:spPr>
           <a:xfrm flipH="1">
-            <a:off x="3252087" y="4364799"/>
+            <a:off x="3709287" y="4364799"/>
             <a:ext cx="285964" cy="0"/>
           </a:xfrm>
           <a:prstGeom prst="line">
@@ -27458,7 +28417,7 @@
         </p:nvCxnSpPr>
         <p:spPr>
           <a:xfrm>
-            <a:off x="3252087" y="4364799"/>
+            <a:off x="3709287" y="4364799"/>
             <a:ext cx="0" cy="233334"/>
           </a:xfrm>
           <a:prstGeom prst="line">
@@ -27496,7 +28455,7 @@
         </p:nvSpPr>
         <p:spPr>
           <a:xfrm>
-            <a:off x="2971123" y="2990719"/>
+            <a:off x="3428323" y="2990719"/>
             <a:ext cx="1280160" cy="182880"/>
           </a:xfrm>
           <a:prstGeom prst="rect">
@@ -27535,7 +28494,7 @@
         </p:nvSpPr>
         <p:spPr>
           <a:xfrm>
-            <a:off x="3663777" y="1918661"/>
+            <a:off x="4120977" y="1918661"/>
             <a:ext cx="173736" cy="173736"/>
           </a:xfrm>
           <a:prstGeom prst="roundRect">
@@ -27582,8 +28541,8 @@
         </p:nvSpPr>
         <p:spPr>
           <a:xfrm>
-            <a:off x="1477877" y="1886657"/>
-            <a:ext cx="1371600" cy="182880"/>
+            <a:off x="4842784" y="1886657"/>
+            <a:ext cx="777240" cy="182880"/>
           </a:xfrm>
           <a:prstGeom prst="rect">
             <a:avLst/>
@@ -27596,7 +28555,7 @@
           </a:bodyPr>
           <a:lstStyle/>
           <a:p>
-            <a:pPr algn="r">
+            <a:pPr algn="l">
               <a:lnSpc>
                 <a:spcPct val="118000"/>
               </a:lnSpc>
@@ -27621,8 +28580,8 @@
         </p:nvSpPr>
         <p:spPr>
           <a:xfrm>
-            <a:off x="1477877" y="2051249"/>
-            <a:ext cx="1371600" cy="182880"/>
+            <a:off x="4842784" y="2051249"/>
+            <a:ext cx="777240" cy="182880"/>
           </a:xfrm>
           <a:prstGeom prst="rect">
             <a:avLst/>
@@ -27635,7 +28594,7 @@
           </a:bodyPr>
           <a:lstStyle/>
           <a:p>
-            <a:pPr algn="r">
+            <a:pPr algn="l">
               <a:lnSpc>
                 <a:spcPct val="118000"/>
               </a:lnSpc>
@@ -27660,7 +28619,7 @@
         </p:nvSpPr>
         <p:spPr>
           <a:xfrm>
-            <a:off x="3009548" y="1886657"/>
+            <a:off x="3879282" y="1737360"/>
             <a:ext cx="237744" cy="237744"/>
           </a:xfrm>
           <a:prstGeom prst="roundRect">
@@ -27707,7 +28666,7 @@
         </p:nvSpPr>
         <p:spPr>
           <a:xfrm>
-            <a:off x="3009548" y="1927805"/>
+            <a:off x="3879282" y="1778508"/>
             <a:ext cx="237744" cy="182880"/>
           </a:xfrm>
           <a:prstGeom prst="rect">
@@ -27746,7 +28705,7 @@
         </p:nvSpPr>
         <p:spPr>
           <a:xfrm>
-            <a:off x="3548809" y="3027403"/>
+            <a:off x="4006009" y="3027403"/>
             <a:ext cx="237744" cy="237744"/>
           </a:xfrm>
           <a:prstGeom prst="roundRect">
@@ -27793,7 +28752,7 @@
         </p:nvSpPr>
         <p:spPr>
           <a:xfrm>
-            <a:off x="3548809" y="3068551"/>
+            <a:off x="4006009" y="3068551"/>
             <a:ext cx="237744" cy="182880"/>
           </a:xfrm>
           <a:prstGeom prst="rect">
@@ -27832,7 +28791,7 @@
         </p:nvSpPr>
         <p:spPr>
           <a:xfrm>
-            <a:off x="3345808" y="4790373"/>
+            <a:off x="3803008" y="4790373"/>
             <a:ext cx="237744" cy="237744"/>
           </a:xfrm>
           <a:prstGeom prst="roundRect">
@@ -27879,7 +28838,7 @@
         </p:nvSpPr>
         <p:spPr>
           <a:xfrm>
-            <a:off x="3345808" y="4831521"/>
+            <a:off x="3803008" y="4831521"/>
             <a:ext cx="237744" cy="182880"/>
           </a:xfrm>
           <a:prstGeom prst="rect">
@@ -27918,7 +28877,7 @@
         </p:nvSpPr>
         <p:spPr>
           <a:xfrm>
-            <a:off x="1992469" y="5697785"/>
+            <a:off x="2449669" y="5697785"/>
             <a:ext cx="237744" cy="237744"/>
           </a:xfrm>
           <a:prstGeom prst="roundRect">
@@ -27965,7 +28924,7 @@
         </p:nvSpPr>
         <p:spPr>
           <a:xfrm>
-            <a:off x="1992469" y="5738933"/>
+            <a:off x="2449669" y="5738933"/>
             <a:ext cx="237744" cy="182880"/>
           </a:xfrm>
           <a:prstGeom prst="rect">
@@ -28004,7 +28963,7 @@
         </p:nvSpPr>
         <p:spPr>
           <a:xfrm>
-            <a:off x="2070248" y="3784443"/>
+            <a:off x="2527448" y="3784443"/>
             <a:ext cx="237744" cy="237744"/>
           </a:xfrm>
           <a:prstGeom prst="roundRect">
@@ -28051,7 +29010,7 @@
         </p:nvSpPr>
         <p:spPr>
           <a:xfrm>
-            <a:off x="2070248" y="3825591"/>
+            <a:off x="2527448" y="3825591"/>
             <a:ext cx="237744" cy="182880"/>
           </a:xfrm>
           <a:prstGeom prst="rect">
@@ -28090,7 +29049,7 @@
         </p:nvCxnSpPr>
         <p:spPr>
           <a:xfrm>
-            <a:off x="670632" y="6309251"/>
+            <a:off x="1127832" y="6309251"/>
             <a:ext cx="1037041" cy="0"/>
           </a:xfrm>
           <a:prstGeom prst="line">
@@ -28126,7 +29085,7 @@
         </p:nvSpPr>
         <p:spPr>
           <a:xfrm>
-            <a:off x="1753393" y="6290000"/>
+            <a:off x="2210593" y="6290000"/>
             <a:ext cx="457200" cy="164592"/>
           </a:xfrm>
           <a:prstGeom prst="rect">

</xml_diff>